<commit_message>
Slides: sessions 05 and 28; others in progress
Co-Authored-By: Claude Opus 5.5 <noreply@anthropic.com>
Claude-Session: https://claude.ai/code/session_01XkzKv8pUGMF9AsqSCMpnBq
</commit_message>
<xml_diff>
--- a/slides/decks/s16-neurological.pptx
+++ b/slides/decks/s16-neurological.pptx
@@ -31,10 +31,9 @@
     <p:sldId id="279" r:id="rId25"/>
     <p:sldId id="280" r:id="rId26"/>
     <p:sldId id="281" r:id="rId27"/>
-    <p:sldId id="282" r:id="rId28"/>
   </p:sldIdLst>
   <p:notesMasterIdLst>
-    <p:notesMasterId r:id="rId29"/>
+    <p:notesMasterId r:id="rId28"/>
   </p:notesMasterIdLst>
   <p:sldSz cx="12192000" cy="6858000"/>
   <p:notesSz cx="6858000" cy="12192000"/>
@@ -133,20 +132,20 @@
   <p:extLst>
     <p:ext uri="{521415D9-36F7-43E2-AB2F-B90AF26B5E84}">
       <p14:sectionLst xmlns:p14="http://schemas.microsoft.com/office/powerpoint/2010/main">
-        <p14:section name="Opening" id="{aa022950-ee01-4c12-8154-23db2bafc739}">
+        <p14:section name="Opening" id="{b5fee39f-2e5d-77fe-719b-4371d239a9b8}">
           <p14:sldIdLst>
             <p14:sldId id="256"/>
             <p14:sldId id="257"/>
           </p14:sldIdLst>
         </p14:section>
-        <p14:section name="Scope and causes" id="{052375a8-3e16-65b5-ef78-8899a3609a2c}">
+        <p14:section name="Scope and causes" id="{661ee6bc-fd7c-73fe-31a6-c99d43ecfc88}">
           <p14:sldIdLst>
             <p14:sldId id="258"/>
             <p14:sldId id="259"/>
             <p14:sldId id="260"/>
           </p14:sldIdLst>
         </p14:section>
-        <p14:section name="Neurotoxic drugs and PRES" id="{d0178598-27c1-6e52-9e44-92aebac5a968}">
+        <p14:section name="Neurotoxic drugs and PRES" id="{db64a90d-d6df-1e12-3778-d52f278059f1}">
           <p14:sldIdLst>
             <p14:sldId id="261"/>
             <p14:sldId id="262"/>
@@ -154,7 +153,7 @@
             <p14:sldId id="264"/>
           </p14:sldIdLst>
         </p14:section>
-        <p14:section name="Infection, vascular, metabolic, immune" id="{a95ab94c-79a0-741c-31fd-6c2b583b3f67}">
+        <p14:section name="Infection, vascular, metabolic, immune" id="{f1cf36a1-d3a3-a91e-332e-8be9f4cc7726}">
           <p14:sldIdLst>
             <p14:sldId id="265"/>
             <p14:sldId id="266"/>
@@ -163,13 +162,13 @@
             <p14:sldId id="269"/>
           </p14:sldIdLst>
         </p14:section>
-        <p14:section name="Work-up" id="{1c81f503-95a2-d3ce-8cbd-5de575ceb79a}">
+        <p14:section name="Work-up" id="{3f120cba-37f4-bc74-04a6-5a0cfa61b68d}">
           <p14:sldIdLst>
             <p14:sldId id="270"/>
             <p14:sldId id="271"/>
           </p14:sldIdLst>
         </p14:section>
-        <p14:section name="Board questions" id="{de60cf58-cfa0-81dd-b772-b4f560ac894f}">
+        <p14:section name="Board questions" id="{075e5961-e302-4235-ba16-811f2848be7b}">
           <p14:sldIdLst>
             <p14:sldId id="272"/>
             <p14:sldId id="273"/>
@@ -179,17 +178,16 @@
             <p14:sldId id="277"/>
           </p14:sldIdLst>
         </p14:section>
-        <p14:section name="References" id="{60570259-a8d4-6593-7734-998a4066b631}">
+        <p14:section name="References" id="{6bb0496f-1a95-6edd-51cc-92eae5eadc62}">
           <p14:sldIdLst>
             <p14:sldId id="278"/>
-            <p14:sldId id="279"/>
           </p14:sldIdLst>
         </p14:section>
-        <p14:section name="Backup" id="{299505ae-2014-83fa-2715-4cd5c562e834}">
+        <p14:section name="Backup" id="{d4a29e2d-97bc-0cc0-dcf5-8733b621a3d3}">
           <p14:sldIdLst>
+            <p14:sldId id="279"/>
             <p14:sldId id="280"/>
             <p14:sldId id="281"/>
-            <p14:sldId id="282"/>
           </p14:sldIdLst>
         </p14:section>
       </p14:sectionLst>
@@ -781,7 +779,7 @@
             </a:pPr>
             <a:r>
               <a:rPr lang="en-US" dirty="0"/>
-              <a:t>使用這張表的方法是先看影像型態，再決定 CSF 要送哪些 PCR。局部多發病灶想 Toxoplasma、Nocardia 或黴菌；內側顳葉的 limbic pattern 想 HHV-6 和 HSV；白質多發、沒有占位效應、移植後幾個月才出現的，要想 PML。書上也說，早期的 preemptive 或標靶治療，是改善 CNS 感染預後的關鍵，不要等培養結果才開始用藥。</a:t>
+              <a:t>使用這張表的方法是先看影像型態，再決定 CSF 要送哪些 PCR。多發局部病灶想 Toxoplasma 或 Nocardia 的腦膿瘍；limbic encephalitis 的型態想 HHV-6；移植後數個月、用過 rituximab 的病人要想 PML。書上也說，早期的 preemptive 或標靶治療，是改善 CNS 感染預後的關鍵，不要等培養結果才開始用藥。</a:t>
             </a:r>
           </a:p>
           <a:p>
@@ -928,7 +926,7 @@
             </a:pPr>
             <a:r>
               <a:rPr lang="en-US" dirty="0"/>
-              <a:t>中間是出血。硬腦膜下血腫是最常見的一種，發生率 2.6%。危險因子包括移植後跌倒、長期嚴重血小板低下或輸注無效、grade III 到 IV 的 aGVHD，以及高血壓。要記住一個數字，CT 通常可以確診，但 20 到 25% 的 CNS 出血病人 CT 是陰性的，臨床懷疑高就要再做 MRI 或追蹤。</a:t>
+              <a:t>中間是出血。硬腦膜下血腫是最常見的一種，發生率 2.6%。危險因子包括移植後跌倒、長期嚴重血小板低下或輸注無效、grade III 到 IV 的 aGVHD，以及高血壓。要記住一個數字，CT 通常可以確診，但 20 到 25% 的 CNS 出血病人 CT 是陰性的，臨床懷疑高時，不能因為 CT 陰性就排除出血。</a:t>
             </a:r>
           </a:p>
           <a:p>
@@ -1119,7 +1117,7 @@
             </a:pPr>
             <a:r>
               <a:rPr lang="en-US" dirty="0"/>
-              <a:t>考試常把三者放在同一題當選項。表現是對稱性上行性無力加反射消失，就是 Guillain-Barré，先給 IVIG；近端肌無力加 CK 上升，是 myositis，用類固醇；眼瞼下垂和複視，症狀在一天之內會波動，就要想 myasthenia，用 cholinesterase inhibitor 加類固醇。Guillain-Barré 的病人要特別注意呼吸功能，肺活量下降時要及早轉加護病房。</a:t>
+              <a:t>考試常把三者放在同一題當選項。表現是對稱性上行性無力加反射消失，就是 Guillain-Barré，先給 IVIG；近端肌無力加 CK 上升，是 myositis，用類固醇；眼瞼下垂、複視和吞嚥困難，出現在 GVHD 之後，就要想 myasthenia，用 cholinesterase inhibitor 加類固醇。Guillain-Barré 的病人可能出現呼吸功能不全，書上把它列為最常見的症狀之一，所以要盡快完成 MRI、腰椎穿刺和神經傳導檢查，不要拖延治療。</a:t>
             </a:r>
           </a:p>
         </p:txBody>
@@ -1233,7 +1231,7 @@
             </a:pPr>
             <a:r>
               <a:rPr lang="en-US" dirty="0"/>
-              <a:t>第一種是脫髓鞘疾病，可以出現在大腦白質、視神經和脊髓，病程像 multiple sclerosis 一樣 relapsing-remitting。治療用類固醇脈衝，難治或復發的病人可以考慮 sphingosine-1-phosphate receptor agonist，例如 fingolimod，這是 Gauthier 2018 的報告。</a:t>
+              <a:t>第一種是脫髓鞘疾病，可以出現在大腦白質、視神經和脊髓，病程像 multiple sclerosis 一樣 relapsing-remitting。治療用類固醇脈衝，難治或復發的病人可以考慮 sphingosine-1-phosphate receptor agonist，例如 fingolimod，證據來自病例報告。</a:t>
             </a:r>
           </a:p>
           <a:p>
@@ -1710,17 +1708,6 @@
               <a:t>考試若問第一步做什麼，答案通常是回顧用藥史和代謝問題，而不是直接做切片。</a:t>
             </a:r>
           </a:p>
-          <a:p>
-            <a:pPr>
-              <a:spcAft>
-                <a:spcPts val="600"/>
-              </a:spcAft>
-            </a:pPr>
-            <a:r>
-              <a:rPr lang="en-US" dirty="0"/>
-              <a:t>CSF 也可以看是否有血液疾病在 CNS 復發，這點在 ALL 和高風險 AML 的病人尤其要記得送細胞學。</a:t>
-            </a:r>
-          </a:p>
         </p:txBody>
       </p:sp>
       <p:sp>
@@ -2648,7 +2635,7 @@
             </a:pPr>
             <a:r>
               <a:rPr lang="en-US" dirty="0"/>
-              <a:t>肺活量在掉，代表要密切監測呼吸，必要時轉加護病房，這點在病房比選藥更急。</a:t>
+              <a:t>肺活量在掉，代表呼吸功能不全已經開始，書上把它列為最常見的症狀之一，在病房要和選藥同時處理。</a:t>
             </a:r>
           </a:p>
           <a:p>
@@ -2832,11 +2819,48 @@
           <a:bodyPr/>
           <a:lstStyle/>
           <a:p>
+            <a:pPr>
+              <a:spcAft>
+                <a:spcPts val="600"/>
+              </a:spcAft>
+            </a:pPr>
             <a:r>
               <a:rPr lang="en-US" dirty="0"/>
-              <a:t>各頁頁尾短式引用的完整文獻，不講。</a:t>
-            </a:r>
-            <a:endParaRPr lang="en-US" dirty="0"/>
+              <a:t>PML 的診斷分級來自第 38 章。Definite 要臨床、影像和 CSF JCV PCR 三者都有；probable 和 possible 的定義在書上有重疊。</a:t>
+            </a:r>
+          </a:p>
+          <a:p>
+            <a:pPr>
+              <a:spcAft>
+                <a:spcPts val="600"/>
+              </a:spcAft>
+            </a:pPr>
+            <a:r>
+              <a:rPr lang="en-US" dirty="0"/>
+              <a:t>沒有特效藥，靠免疫重建，G-CSF、JCV 特異性 CTL 和 PD-1 抗體只有初步經驗。</a:t>
+            </a:r>
+          </a:p>
+          <a:p>
+            <a:pPr>
+              <a:spcAft>
+                <a:spcPts val="600"/>
+              </a:spcAft>
+            </a:pPr>
+            <a:r>
+              <a:rPr lang="en-US" b="1" dirty="0"/>
+              <a:t>講者提醒（不念出來）：</a:t>
+            </a:r>
+          </a:p>
+          <a:p>
+            <a:pPr>
+              <a:spcAft>
+                <a:spcPts val="600"/>
+              </a:spcAft>
+            </a:pPr>
+            <a:r>
+              <a:rPr lang="en-US" dirty="0"/>
+              <a:t>- Ch. 38 is internally inconsistent: it says biopsy is required for a definitive diagnosis, then defines 'definite' PML without biopsy; 'probable' and 'possible' overlap (CSF PCR alone fits both).</a:t>
+            </a:r>
           </a:p>
         </p:txBody>
       </p:sp>
@@ -2927,7 +2951,7 @@
             </a:pPr>
             <a:r>
               <a:rPr lang="en-US" dirty="0"/>
-              <a:t>PML 的診斷分級來自第 38 章。Definite 要臨床、影像和 CSF JCV PCR 三者都有；probable 和 possible 的定義在書上有重疊。</a:t>
+              <a:t>Toxoplasma 腦炎的治療和預防劑量來自第 39 章 Table 39.2。TMP/SMX 每週少於三天時曾有 breakthrough。</a:t>
             </a:r>
           </a:p>
           <a:p>
@@ -2938,29 +2962,7 @@
             </a:pPr>
             <a:r>
               <a:rPr lang="en-US" dirty="0"/>
-              <a:t>沒有特效藥，靠免疫重建，G-CSF、JCV 特異性 CTL 和 PD-1 抗體只有初步經驗。</a:t>
-            </a:r>
-          </a:p>
-          <a:p>
-            <a:pPr>
-              <a:spcAft>
-                <a:spcPts val="600"/>
-              </a:spcAft>
-            </a:pPr>
-            <a:r>
-              <a:rPr lang="en-US" b="1" dirty="0"/>
-              <a:t>講者提醒（不念出來）：</a:t>
-            </a:r>
-          </a:p>
-          <a:p>
-            <a:pPr>
-              <a:spcAft>
-                <a:spcPts val="600"/>
-              </a:spcAft>
-            </a:pPr>
-            <a:r>
-              <a:rPr lang="en-US" dirty="0"/>
-              <a:t>- Ch. 38 is internally inconsistent: it says biopsy is required for a definitive diagnosis, then defines 'definite' PML without biopsy; 'probable' and 'possible' overlap (CSF PCR alone fits both).</a:t>
+              <a:t>血清陽性又沒有用 TMP/SMX 預防的病人，可以每週驗血液 qPCR 做 preemptive 治療。</a:t>
             </a:r>
           </a:p>
         </p:txBody>
@@ -3052,7 +3054,7 @@
             </a:pPr>
             <a:r>
               <a:rPr lang="en-US" dirty="0"/>
-              <a:t>Toxoplasma 腦炎的治療和預防劑量來自第 39 章 Table 39.2。TMP/SMX 每週少於三天時曾有 breakthrough。</a:t>
+              <a:t>第 37 章的劑量。Cerebral aspergillosis 首選 voriconazole 或 isavuconazole，posaconazole 的 CNS 穿透有限。</a:t>
             </a:r>
           </a:p>
           <a:p>
@@ -3063,7 +3065,7 @@
             </a:pPr>
             <a:r>
               <a:rPr lang="en-US" dirty="0"/>
-              <a:t>血清陽性又沒有用 TMP/SMX 預防的病人，可以每週驗血液 qPCR 做 preemptive 治療。</a:t>
+              <a:t>Mucormycosis 首選 lipid-based amphotericin B，CNS 感染優先用 liposomal 劑型，和第 53 章的寫法不同。</a:t>
             </a:r>
           </a:p>
         </p:txBody>
@@ -3086,109 +3088,6 @@
             <a:fld id="{F7021451-1387-4CA6-816F-3879F97B5CBC}" type="slidenum">
               <a:rPr lang="en-US"/>
               <a:t>26</a:t>
-            </a:fld>
-            <a:endParaRPr lang="en-US"/>
-          </a:p>
-        </p:txBody>
-      </p:sp>
-    </p:spTree>
-    <p:extLst>
-      <p:ext uri="{BB962C8B-B14F-4D97-AF65-F5344CB8AC3E}">
-        <p14:creationId xmlns:p14="http://schemas.microsoft.com/office/powerpoint/2010/main" val="1024086991"/>
-      </p:ext>
-    </p:extLst>
-  </p:cSld>
-  <p:clrMapOvr>
-    <a:masterClrMapping/>
-  </p:clrMapOvr>
-</p:notes>
-</file>
-
-<file path=ppt/notesSlides/notesSlide27.xml><?xml version="1.0" encoding="utf-8"?>
-<p:notes xmlns:a="http://schemas.openxmlformats.org/drawingml/2006/main" xmlns:r="http://schemas.openxmlformats.org/officeDocument/2006/relationships" xmlns:p="http://schemas.openxmlformats.org/presentationml/2006/main">
-  <p:cSld>
-    <p:spTree>
-      <p:nvGrpSpPr>
-        <p:cNvPr id="1" name=""/>
-        <p:cNvGrpSpPr/>
-        <p:nvPr/>
-      </p:nvGrpSpPr>
-      <p:grpSpPr>
-        <a:xfrm>
-          <a:off x="0" y="0"/>
-          <a:ext cx="0" cy="0"/>
-          <a:chOff x="0" y="0"/>
-          <a:chExt cx="0" cy="0"/>
-        </a:xfrm>
-      </p:grpSpPr>
-      <p:sp>
-        <p:nvSpPr>
-          <p:cNvPr id="2" name="Slide Image Placeholder 1"/>
-          <p:cNvSpPr>
-            <a:spLocks noGrp="1" noRot="1" noChangeAspect="1"/>
-          </p:cNvSpPr>
-          <p:nvPr>
-            <p:ph type="sldImg"/>
-          </p:nvPr>
-        </p:nvSpPr>
-        <p:spPr/>
-      </p:sp>
-      <p:sp>
-        <p:nvSpPr>
-          <p:cNvPr id="3" name="Notes Placeholder 2"/>
-          <p:cNvSpPr>
-            <a:spLocks noGrp="1"/>
-          </p:cNvSpPr>
-          <p:nvPr>
-            <p:ph type="body" idx="1"/>
-          </p:nvPr>
-        </p:nvSpPr>
-        <p:spPr/>
-        <p:txBody>
-          <a:bodyPr/>
-          <a:lstStyle/>
-          <a:p>
-            <a:pPr>
-              <a:spcAft>
-                <a:spcPts val="600"/>
-              </a:spcAft>
-            </a:pPr>
-            <a:r>
-              <a:rPr lang="en-US" dirty="0"/>
-              <a:t>第 37 章的劑量。Cerebral aspergillosis 首選 voriconazole 或 isavuconazole，posaconazole 的 CNS 穿透有限。</a:t>
-            </a:r>
-          </a:p>
-          <a:p>
-            <a:pPr>
-              <a:spcAft>
-                <a:spcPts val="600"/>
-              </a:spcAft>
-            </a:pPr>
-            <a:r>
-              <a:rPr lang="en-US" dirty="0"/>
-              <a:t>Mucormycosis 首選 lipid-based amphotericin B，CNS 感染優先用 liposomal 劑型，和第 53 章的寫法不同。</a:t>
-            </a:r>
-          </a:p>
-        </p:txBody>
-      </p:sp>
-      <p:sp>
-        <p:nvSpPr>
-          <p:cNvPr id="4" name="Slide Number Placeholder 3"/>
-          <p:cNvSpPr>
-            <a:spLocks noGrp="1"/>
-          </p:cNvSpPr>
-          <p:nvPr>
-            <p:ph type="sldNum" sz="quarter" idx="10"/>
-          </p:nvPr>
-        </p:nvSpPr>
-        <p:spPr/>
-        <p:txBody>
-          <a:bodyPr/>
-          <a:lstStyle/>
-          <a:p>
-            <a:fld id="{F7021451-1387-4CA6-816F-3879F97B5CBC}" type="slidenum">
-              <a:rPr lang="en-US"/>
-              <a:t>27</a:t>
             </a:fld>
             <a:endParaRPr lang="en-US"/>
           </a:p>
@@ -3588,17 +3487,6 @@
               <a:t>臨床症狀常常不典型，時間點是少數可以快速縮小範圍的線索。</a:t>
             </a:r>
           </a:p>
-          <a:p>
-            <a:pPr>
-              <a:spcAft>
-                <a:spcPts val="600"/>
-              </a:spcAft>
-            </a:pPr>
-            <a:r>
-              <a:rPr lang="en-US" dirty="0"/>
-              <a:t>所以先問移植第幾天、用什麼藥、有沒有 GVHD，就能把七大類縮成兩三類。</a:t>
-            </a:r>
-          </a:p>
         </p:txBody>
       </p:sp>
       <p:sp>
@@ -4206,7 +4094,7 @@
             </a:pPr>
             <a:r>
               <a:rPr lang="en-US" dirty="0"/>
-              <a:t>危險因子要背。腎功能差、年紀大、fludarabine 劑量高、之前有 CNS 疾病，或之前已經接受過 fludarabine-based 的 conditioning。Fludarabine 經腎臟排除，所以腎功能差的老年人用 Flu-based RIC 時要特別小心。</a:t>
+              <a:t>危險因子要背。腎功能差、年紀大、fludarabine 劑量高、之前有 CNS 疾病，或之前已經接受過 fludarabine-based 的 conditioning。所以腎功能差的老年病人用 Flu-based RIC 時要特別小心，這是我從危險因子推出來的。</a:t>
             </a:r>
           </a:p>
           <a:p>
@@ -5637,7 +5525,7 @@
       </p:sp>
       <p:graphicFrame>
         <p:nvGraphicFramePr>
-          <p:cNvPr id="11" name="Table 46"/>
+          <p:cNvPr id="11" name="Table 45"/>
           <p:cNvGraphicFramePr>
             <a:graphicFrameLocks noGrp="1"/>
           </p:cNvGraphicFramePr>
@@ -7335,7 +7223,7 @@
       </p:sp>
       <p:sp>
         <p:nvSpPr>
-          <p:cNvPr id="6" name="Text 47"/>
+          <p:cNvPr id="6" name="Text 46"/>
           <p:cNvSpPr txBox="1"/>
           <p:nvPr/>
         </p:nvSpPr>
@@ -7394,7 +7282,7 @@
       </p:sp>
       <p:sp>
         <p:nvSpPr>
-          <p:cNvPr id="8" name="Text 48"/>
+          <p:cNvPr id="8" name="Text 47"/>
           <p:cNvSpPr txBox="1"/>
           <p:nvPr/>
         </p:nvSpPr>
@@ -7506,7 +7394,7 @@
       </p:sp>
       <p:sp>
         <p:nvSpPr>
-          <p:cNvPr id="9" name="Text 49"/>
+          <p:cNvPr id="9" name="Text 48"/>
           <p:cNvSpPr txBox="1"/>
           <p:nvPr/>
         </p:nvSpPr>
@@ -7565,7 +7453,7 @@
       </p:sp>
       <p:sp>
         <p:nvSpPr>
-          <p:cNvPr id="11" name="Text 50"/>
+          <p:cNvPr id="11" name="Text 49"/>
           <p:cNvSpPr txBox="1"/>
           <p:nvPr/>
         </p:nvSpPr>
@@ -7677,7 +7565,7 @@
       </p:sp>
       <p:sp>
         <p:nvSpPr>
-          <p:cNvPr id="12" name="Text 51"/>
+          <p:cNvPr id="12" name="Text 50"/>
           <p:cNvSpPr txBox="1"/>
           <p:nvPr/>
         </p:nvSpPr>
@@ -7736,7 +7624,7 @@
       </p:sp>
       <p:sp>
         <p:nvSpPr>
-          <p:cNvPr id="14" name="Text 52"/>
+          <p:cNvPr id="14" name="Text 51"/>
           <p:cNvSpPr txBox="1"/>
           <p:nvPr/>
         </p:nvSpPr>
@@ -8032,7 +7920,7 @@
       </p:sp>
       <p:graphicFrame>
         <p:nvGraphicFramePr>
-          <p:cNvPr id="13" name="Table 53"/>
+          <p:cNvPr id="13" name="Table 52"/>
           <p:cNvGraphicFramePr>
             <a:graphicFrameLocks noGrp="1"/>
           </p:cNvGraphicFramePr>
@@ -8903,13 +8791,13 @@
       </p:graphicFrame>
       <p:sp>
         <p:nvSpPr>
-          <p:cNvPr id="7" name="Text 54"/>
+          <p:cNvPr id="7" name="Text 53"/>
           <p:cNvSpPr txBox="1"/>
           <p:nvPr/>
         </p:nvSpPr>
         <p:spPr>
           <a:xfrm>
-            <a:off x="685800" y="5120640"/>
+            <a:off x="685800" y="4709160"/>
             <a:ext cx="10817352" cy="411480"/>
           </a:xfrm>
           <a:prstGeom prst="rect">
@@ -9123,7 +9011,7 @@
       </p:sp>
       <p:sp>
         <p:nvSpPr>
-          <p:cNvPr id="6" name="Box 55"/>
+          <p:cNvPr id="6" name="Box 54"/>
           <p:cNvSpPr txBox="1"/>
           <p:nvPr/>
         </p:nvSpPr>
@@ -9235,7 +9123,7 @@
       </p:sp>
       <p:sp>
         <p:nvSpPr>
-          <p:cNvPr id="10" name="Text 56"/>
+          <p:cNvPr id="10" name="Text 55"/>
           <p:cNvSpPr txBox="1"/>
           <p:nvPr/>
         </p:nvSpPr>
@@ -9273,7 +9161,7 @@
       </p:sp>
       <p:sp>
         <p:nvSpPr>
-          <p:cNvPr id="11" name="Box 57"/>
+          <p:cNvPr id="11" name="Box 56"/>
           <p:cNvSpPr txBox="1"/>
           <p:nvPr/>
         </p:nvSpPr>
@@ -9339,7 +9227,7 @@
       </p:sp>
       <p:sp>
         <p:nvSpPr>
-          <p:cNvPr id="13" name="Box 58"/>
+          <p:cNvPr id="13" name="Box 57"/>
           <p:cNvSpPr txBox="1"/>
           <p:nvPr/>
         </p:nvSpPr>
@@ -9405,7 +9293,7 @@
       </p:sp>
       <p:sp>
         <p:nvSpPr>
-          <p:cNvPr id="15" name="Text 59"/>
+          <p:cNvPr id="15" name="Text 58"/>
           <p:cNvSpPr txBox="1"/>
           <p:nvPr/>
         </p:nvSpPr>
@@ -9443,7 +9331,7 @@
       </p:sp>
       <p:sp>
         <p:nvSpPr>
-          <p:cNvPr id="16" name="Box 60"/>
+          <p:cNvPr id="16" name="Box 59"/>
           <p:cNvSpPr txBox="1"/>
           <p:nvPr/>
         </p:nvSpPr>
@@ -9509,7 +9397,7 @@
       </p:sp>
       <p:sp>
         <p:nvSpPr>
-          <p:cNvPr id="18" name="Box 61"/>
+          <p:cNvPr id="18" name="Box 60"/>
           <p:cNvSpPr txBox="1"/>
           <p:nvPr/>
         </p:nvSpPr>
@@ -9575,7 +9463,7 @@
       </p:sp>
       <p:sp>
         <p:nvSpPr>
-          <p:cNvPr id="20" name="Text 62"/>
+          <p:cNvPr id="20" name="Text 61"/>
           <p:cNvSpPr txBox="1"/>
           <p:nvPr/>
         </p:nvSpPr>
@@ -9613,7 +9501,7 @@
       </p:sp>
       <p:sp>
         <p:nvSpPr>
-          <p:cNvPr id="21" name="Box 63"/>
+          <p:cNvPr id="21" name="Box 62"/>
           <p:cNvSpPr txBox="1"/>
           <p:nvPr/>
         </p:nvSpPr>
@@ -9679,7 +9567,7 @@
       </p:sp>
       <p:sp>
         <p:nvSpPr>
-          <p:cNvPr id="23" name="Box 64"/>
+          <p:cNvPr id="23" name="Box 63"/>
           <p:cNvSpPr txBox="1"/>
           <p:nvPr/>
         </p:nvSpPr>
@@ -9905,7 +9793,7 @@
       </p:sp>
       <p:sp>
         <p:nvSpPr>
-          <p:cNvPr id="6" name="Text 65"/>
+          <p:cNvPr id="6" name="Text 64"/>
           <p:cNvSpPr txBox="1"/>
           <p:nvPr/>
         </p:nvSpPr>
@@ -9944,7 +9832,7 @@
       </p:sp>
       <p:sp>
         <p:nvSpPr>
-          <p:cNvPr id="7" name="Text 66"/>
+          <p:cNvPr id="7" name="Text 65"/>
           <p:cNvSpPr txBox="1"/>
           <p:nvPr/>
         </p:nvSpPr>
@@ -9980,7 +9868,7 @@
       </p:sp>
       <p:sp>
         <p:nvSpPr>
-          <p:cNvPr id="8" name="Text 67"/>
+          <p:cNvPr id="8" name="Text 66"/>
           <p:cNvSpPr txBox="1"/>
           <p:nvPr/>
         </p:nvSpPr>
@@ -10019,7 +9907,7 @@
       </p:sp>
       <p:sp>
         <p:nvSpPr>
-          <p:cNvPr id="9" name="Text 68"/>
+          <p:cNvPr id="9" name="Text 67"/>
           <p:cNvSpPr txBox="1"/>
           <p:nvPr/>
         </p:nvSpPr>
@@ -10055,7 +9943,7 @@
       </p:sp>
       <p:sp>
         <p:nvSpPr>
-          <p:cNvPr id="10" name="Rule 69"/>
+          <p:cNvPr id="10" name="Rule 68"/>
           <p:cNvSpPr/>
           <p:nvPr/>
         </p:nvSpPr>
@@ -10078,7 +9966,7 @@
       </p:sp>
       <p:sp>
         <p:nvSpPr>
-          <p:cNvPr id="11" name="Text 70"/>
+          <p:cNvPr id="11" name="Text 69"/>
           <p:cNvSpPr txBox="1"/>
           <p:nvPr/>
         </p:nvSpPr>
@@ -10298,7 +10186,7 @@
       </p:sp>
       <p:sp>
         <p:nvSpPr>
-          <p:cNvPr id="6" name="Box 71"/>
+          <p:cNvPr id="6" name="Box 70"/>
           <p:cNvSpPr txBox="1"/>
           <p:nvPr/>
         </p:nvSpPr>
@@ -10364,7 +10252,7 @@
       </p:sp>
       <p:sp>
         <p:nvSpPr>
-          <p:cNvPr id="8" name="Box 72"/>
+          <p:cNvPr id="8" name="Box 71"/>
           <p:cNvSpPr txBox="1"/>
           <p:nvPr/>
         </p:nvSpPr>
@@ -10430,7 +10318,7 @@
       </p:sp>
       <p:sp>
         <p:nvSpPr>
-          <p:cNvPr id="10" name="Box 73"/>
+          <p:cNvPr id="10" name="Box 72"/>
           <p:cNvSpPr txBox="1"/>
           <p:nvPr/>
         </p:nvSpPr>
@@ -10496,7 +10384,7 @@
       </p:sp>
       <p:sp>
         <p:nvSpPr>
-          <p:cNvPr id="12" name="Box 74"/>
+          <p:cNvPr id="12" name="Box 73"/>
           <p:cNvSpPr txBox="1"/>
           <p:nvPr/>
         </p:nvSpPr>
@@ -10562,7 +10450,7 @@
       </p:sp>
       <p:sp>
         <p:nvSpPr>
-          <p:cNvPr id="14" name="Box 75"/>
+          <p:cNvPr id="14" name="Box 74"/>
           <p:cNvSpPr txBox="1"/>
           <p:nvPr/>
         </p:nvSpPr>
@@ -10604,7 +10492,7 @@
       </p:sp>
       <p:sp>
         <p:nvSpPr>
-          <p:cNvPr id="15" name="Text 76"/>
+          <p:cNvPr id="15" name="Text 75"/>
           <p:cNvSpPr txBox="1"/>
           <p:nvPr/>
         </p:nvSpPr>
@@ -10778,7 +10666,7 @@
                   <a:schemeClr val="tx1"/>
                 </a:solidFill>
               </a:rPr>
-              <a:t>Each test in the work-up answers a specific question</a:t>
+              <a:t>Each test answers a specific diagnostic question</a:t>
             </a:r>
             <a:endParaRPr lang="en-US" sz="3600" dirty="0"/>
           </a:p>
@@ -10824,7 +10712,7 @@
       </p:sp>
       <p:graphicFrame>
         <p:nvGraphicFramePr>
-          <p:cNvPr id="17" name="Table 77"/>
+          <p:cNvPr id="17" name="Table 76"/>
           <p:cNvGraphicFramePr>
             <a:graphicFrameLocks noGrp="1"/>
           </p:cNvGraphicFramePr>
@@ -12033,7 +11921,7 @@
       </p:sp>
       <p:sp>
         <p:nvSpPr>
-          <p:cNvPr id="6" name="Text 78"/>
+          <p:cNvPr id="6" name="Text 77"/>
           <p:cNvSpPr txBox="1"/>
           <p:nvPr/>
         </p:nvSpPr>
@@ -12069,7 +11957,7 @@
       </p:sp>
       <p:sp>
         <p:nvSpPr>
-          <p:cNvPr id="7" name="Text 79"/>
+          <p:cNvPr id="7" name="Text 78"/>
           <p:cNvSpPr txBox="1"/>
           <p:nvPr/>
         </p:nvSpPr>
@@ -12360,7 +12248,7 @@
       </p:sp>
       <p:sp>
         <p:nvSpPr>
-          <p:cNvPr id="6" name="Box 80"/>
+          <p:cNvPr id="6" name="Box 79"/>
           <p:cNvSpPr txBox="1"/>
           <p:nvPr/>
         </p:nvSpPr>
@@ -12402,7 +12290,7 @@
       </p:sp>
       <p:sp>
         <p:nvSpPr>
-          <p:cNvPr id="7" name="Text 81"/>
+          <p:cNvPr id="7" name="Text 80"/>
           <p:cNvSpPr txBox="1"/>
           <p:nvPr/>
         </p:nvSpPr>
@@ -12622,7 +12510,7 @@
       </p:sp>
       <p:sp>
         <p:nvSpPr>
-          <p:cNvPr id="6" name="Text 82"/>
+          <p:cNvPr id="6" name="Text 81"/>
           <p:cNvSpPr txBox="1"/>
           <p:nvPr/>
         </p:nvSpPr>
@@ -12658,7 +12546,7 @@
       </p:sp>
       <p:sp>
         <p:nvSpPr>
-          <p:cNvPr id="7" name="Text 83"/>
+          <p:cNvPr id="7" name="Text 82"/>
           <p:cNvSpPr txBox="1"/>
           <p:nvPr/>
         </p:nvSpPr>
@@ -12903,7 +12791,7 @@
                   <a:schemeClr val="tx1"/>
                 </a:solidFill>
               </a:rPr>
-              <a:t>Four parts, from the causes to the bedside work-up</a:t>
+              <a:t>Four parts, from causes to the work-up</a:t>
             </a:r>
             <a:endParaRPr lang="en-US" sz="3600" dirty="0"/>
           </a:p>
@@ -12955,7 +12843,7 @@
         </p:nvSpPr>
         <p:spPr>
           <a:xfrm>
-            <a:off x="685800" y="2514600"/>
+            <a:off x="685800" y="2057400"/>
             <a:ext cx="640080" cy="685800"/>
           </a:xfrm>
           <a:prstGeom prst="rect">
@@ -12994,7 +12882,7 @@
         </p:nvSpPr>
         <p:spPr>
           <a:xfrm>
-            <a:off x="1463040" y="2560320"/>
+            <a:off x="1463040" y="2103120"/>
             <a:ext cx="8412480" cy="365760"/>
           </a:xfrm>
           <a:prstGeom prst="rect">
@@ -13030,7 +12918,7 @@
         </p:nvSpPr>
         <p:spPr>
           <a:xfrm>
-            <a:off x="1463040" y="2953512"/>
+            <a:off x="1463040" y="2496312"/>
             <a:ext cx="8412480" cy="320040"/>
           </a:xfrm>
           <a:prstGeom prst="rect">
@@ -13066,7 +12954,7 @@
         </p:nvSpPr>
         <p:spPr>
           <a:xfrm>
-            <a:off x="10058400" y="2606040"/>
+            <a:off x="10058400" y="2148840"/>
             <a:ext cx="1444752" cy="320040"/>
           </a:xfrm>
           <a:prstGeom prst="rect">
@@ -13102,7 +12990,7 @@
         </p:nvSpPr>
         <p:spPr>
           <a:xfrm>
-            <a:off x="685800" y="3328416"/>
+            <a:off x="685800" y="2871216"/>
             <a:ext cx="10817352" cy="0"/>
           </a:xfrm>
           <a:prstGeom prst="line">
@@ -13125,7 +13013,7 @@
         </p:nvSpPr>
         <p:spPr>
           <a:xfrm>
-            <a:off x="685800" y="3429000"/>
+            <a:off x="685800" y="2971800"/>
             <a:ext cx="640080" cy="685800"/>
           </a:xfrm>
           <a:prstGeom prst="rect">
@@ -13164,7 +13052,7 @@
         </p:nvSpPr>
         <p:spPr>
           <a:xfrm>
-            <a:off x="1463040" y="3474720"/>
+            <a:off x="1463040" y="3017520"/>
             <a:ext cx="8412480" cy="365760"/>
           </a:xfrm>
           <a:prstGeom prst="rect">
@@ -13200,7 +13088,7 @@
         </p:nvSpPr>
         <p:spPr>
           <a:xfrm>
-            <a:off x="1463040" y="3867912"/>
+            <a:off x="1463040" y="3410712"/>
             <a:ext cx="8412480" cy="320040"/>
           </a:xfrm>
           <a:prstGeom prst="rect">
@@ -13236,7 +13124,7 @@
         </p:nvSpPr>
         <p:spPr>
           <a:xfrm>
-            <a:off x="10058400" y="3520440"/>
+            <a:off x="10058400" y="3063240"/>
             <a:ext cx="1444752" cy="320040"/>
           </a:xfrm>
           <a:prstGeom prst="rect">
@@ -13272,7 +13160,7 @@
         </p:nvSpPr>
         <p:spPr>
           <a:xfrm>
-            <a:off x="685800" y="4242816"/>
+            <a:off x="685800" y="3785616"/>
             <a:ext cx="10817352" cy="0"/>
           </a:xfrm>
           <a:prstGeom prst="line">
@@ -13295,7 +13183,7 @@
         </p:nvSpPr>
         <p:spPr>
           <a:xfrm>
-            <a:off x="685800" y="4343400"/>
+            <a:off x="685800" y="3886200"/>
             <a:ext cx="640080" cy="685800"/>
           </a:xfrm>
           <a:prstGeom prst="rect">
@@ -13334,7 +13222,7 @@
         </p:nvSpPr>
         <p:spPr>
           <a:xfrm>
-            <a:off x="1463040" y="4389120"/>
+            <a:off x="1463040" y="3931920"/>
             <a:ext cx="8412480" cy="365760"/>
           </a:xfrm>
           <a:prstGeom prst="rect">
@@ -13370,7 +13258,7 @@
         </p:nvSpPr>
         <p:spPr>
           <a:xfrm>
-            <a:off x="1463040" y="4782312"/>
+            <a:off x="1463040" y="4325112"/>
             <a:ext cx="8412480" cy="320040"/>
           </a:xfrm>
           <a:prstGeom prst="rect">
@@ -13406,7 +13294,7 @@
         </p:nvSpPr>
         <p:spPr>
           <a:xfrm>
-            <a:off x="10058400" y="4434840"/>
+            <a:off x="10058400" y="3977640"/>
             <a:ext cx="1444752" cy="320040"/>
           </a:xfrm>
           <a:prstGeom prst="rect">
@@ -13442,7 +13330,7 @@
         </p:nvSpPr>
         <p:spPr>
           <a:xfrm>
-            <a:off x="685800" y="5157216"/>
+            <a:off x="685800" y="4700016"/>
             <a:ext cx="10817352" cy="0"/>
           </a:xfrm>
           <a:prstGeom prst="line">
@@ -13465,7 +13353,7 @@
         </p:nvSpPr>
         <p:spPr>
           <a:xfrm>
-            <a:off x="685800" y="5257800"/>
+            <a:off x="685800" y="4800600"/>
             <a:ext cx="640080" cy="685800"/>
           </a:xfrm>
           <a:prstGeom prst="rect">
@@ -13504,7 +13392,7 @@
         </p:nvSpPr>
         <p:spPr>
           <a:xfrm>
-            <a:off x="1463040" y="5303520"/>
+            <a:off x="1463040" y="4846320"/>
             <a:ext cx="8412480" cy="365760"/>
           </a:xfrm>
           <a:prstGeom prst="rect">
@@ -13540,7 +13428,7 @@
         </p:nvSpPr>
         <p:spPr>
           <a:xfrm>
-            <a:off x="1463040" y="5696712"/>
+            <a:off x="1463040" y="5239512"/>
             <a:ext cx="8412480" cy="320040"/>
           </a:xfrm>
           <a:prstGeom prst="rect">
@@ -13576,7 +13464,7 @@
         </p:nvSpPr>
         <p:spPr>
           <a:xfrm>
-            <a:off x="10058400" y="5349240"/>
+            <a:off x="10058400" y="4892040"/>
             <a:ext cx="1444752" cy="320040"/>
           </a:xfrm>
           <a:prstGeom prst="rect">
@@ -13790,7 +13678,7 @@
       </p:sp>
       <p:sp>
         <p:nvSpPr>
-          <p:cNvPr id="6" name="Box 84"/>
+          <p:cNvPr id="6" name="Box 83"/>
           <p:cNvSpPr txBox="1"/>
           <p:nvPr/>
         </p:nvSpPr>
@@ -13832,7 +13720,7 @@
       </p:sp>
       <p:sp>
         <p:nvSpPr>
-          <p:cNvPr id="7" name="Text 85"/>
+          <p:cNvPr id="7" name="Text 84"/>
           <p:cNvSpPr txBox="1"/>
           <p:nvPr/>
         </p:nvSpPr>
@@ -14052,7 +13940,7 @@
       </p:sp>
       <p:sp>
         <p:nvSpPr>
-          <p:cNvPr id="6" name="Text 86"/>
+          <p:cNvPr id="6" name="Text 85"/>
           <p:cNvSpPr txBox="1"/>
           <p:nvPr/>
         </p:nvSpPr>
@@ -14088,7 +13976,7 @@
       </p:sp>
       <p:sp>
         <p:nvSpPr>
-          <p:cNvPr id="7" name="Text 87"/>
+          <p:cNvPr id="7" name="Text 86"/>
           <p:cNvSpPr txBox="1"/>
           <p:nvPr/>
         </p:nvSpPr>
@@ -14379,7 +14267,7 @@
       </p:sp>
       <p:sp>
         <p:nvSpPr>
-          <p:cNvPr id="6" name="Box 88"/>
+          <p:cNvPr id="6" name="Box 87"/>
           <p:cNvSpPr txBox="1"/>
           <p:nvPr/>
         </p:nvSpPr>
@@ -14421,7 +14309,7 @@
       </p:sp>
       <p:sp>
         <p:nvSpPr>
-          <p:cNvPr id="7" name="Text 89"/>
+          <p:cNvPr id="7" name="Text 88"/>
           <p:cNvSpPr txBox="1"/>
           <p:nvPr/>
         </p:nvSpPr>
@@ -14595,7 +14483,7 @@
                   <a:schemeClr val="tx1"/>
                 </a:solidFill>
               </a:rPr>
-              <a:t>References, part 1 of 2</a:t>
+              <a:t>References</a:t>
             </a:r>
             <a:endParaRPr lang="en-US" sz="3600" dirty="0"/>
           </a:p>
@@ -14603,7 +14491,7 @@
       </p:sp>
       <p:sp>
         <p:nvSpPr>
-          <p:cNvPr id="5" name="Text 90"/>
+          <p:cNvPr id="5" name="Text 89"/>
           <p:cNvSpPr txBox="1"/>
           <p:nvPr/>
         </p:nvSpPr>
@@ -14672,11 +14560,28 @@
             </a:r>
             <a:endParaRPr lang="en-US" sz="1100" dirty="0"/>
           </a:p>
-        </p:txBody>
-      </p:sp>
-      <p:sp>
-        <p:nvSpPr>
-          <p:cNvPr id="6" name="Text 91"/>
+          <a:p>
+            <a:pPr indent="0" marL="0">
+              <a:spcAft>
+                <a:spcPts val="700"/>
+              </a:spcAft>
+              <a:buNone/>
+            </a:pPr>
+            <a:r>
+              <a:rPr lang="en-US" sz="1100" dirty="0">
+                <a:solidFill>
+                  <a:schemeClr val="tx1"/>
+                </a:solidFill>
+              </a:rPr>
+              <a:t>4. Martino R. Other life-threatening infections. In: Sureda A, Corbacioglu S, Greco R, Kröger N, Carreras E, editors. The EBMT Handbook: Hematopoietic Cell Transplantation and Cellular Therapies. 8th ed. Cham: Springer; 2024. p. 345–54. https://doi.org/10.1007/978-3-031-44080-9_39</a:t>
+            </a:r>
+            <a:endParaRPr lang="en-US" sz="1100" dirty="0"/>
+          </a:p>
+        </p:txBody>
+      </p:sp>
+      <p:sp>
+        <p:nvSpPr>
+          <p:cNvPr id="6" name="Text 90"/>
           <p:cNvSpPr txBox="1"/>
           <p:nvPr/>
         </p:nvSpPr>
@@ -14707,23 +14612,6 @@
                   <a:schemeClr val="tx1"/>
                 </a:solidFill>
               </a:rPr>
-              <a:t>4. Martino R. Other life-threatening infections. In: Sureda A, Corbacioglu S, Greco R, Kröger N, Carreras E, editors. The EBMT Handbook: Hematopoietic Cell Transplantation and Cellular Therapies. 8th ed. Cham: Springer; 2024. p. 345–54. https://doi.org/10.1007/978-3-031-44080-9_39</a:t>
-            </a:r>
-            <a:endParaRPr lang="en-US" sz="1100" dirty="0"/>
-          </a:p>
-          <a:p>
-            <a:pPr indent="0" marL="0">
-              <a:spcAft>
-                <a:spcPts val="700"/>
-              </a:spcAft>
-              <a:buNone/>
-            </a:pPr>
-            <a:r>
-              <a:rPr lang="en-US" sz="1100" dirty="0">
-                <a:solidFill>
-                  <a:schemeClr val="tx1"/>
-                </a:solidFill>
-              </a:rPr>
               <a:t>5. Maertens JA. Invasive fungal diseases. In: Sureda A, Corbacioglu S, Greco R, Kröger N, Carreras E, editors. The EBMT Handbook: Hematopoietic Cell Transplantation and Cellular Therapies. 8th ed. Cham: Springer; 2024. p. 321–9. https://doi.org/10.1007/978-3-031-44080-9_37</a:t>
             </a:r>
             <a:endParaRPr lang="en-US" sz="1100" dirty="0"/>
@@ -14742,6 +14630,40 @@
                 </a:solidFill>
               </a:rPr>
               <a:t>6. Maffini E, Festuccia M, Brunello L, et al. Neurologic complications after allogeneic hematopoietic stem cell transplantation. Biol Blood Marrow Transplant. 2017;23:388–97.</a:t>
+            </a:r>
+            <a:endParaRPr lang="en-US" sz="1100" dirty="0"/>
+          </a:p>
+          <a:p>
+            <a:pPr indent="0" marL="0">
+              <a:spcAft>
+                <a:spcPts val="700"/>
+              </a:spcAft>
+              <a:buNone/>
+            </a:pPr>
+            <a:r>
+              <a:rPr lang="en-US" sz="1100" dirty="0">
+                <a:solidFill>
+                  <a:schemeClr val="tx1"/>
+                </a:solidFill>
+              </a:rPr>
+              <a:t>7. Beitinjaneh A, McKinney AM, Cao Q, Weisdorf DJ. Toxic leukoencephalopathy following fludarabine-associated hematopoietic cell transplantation. Biol Blood Marrow Transplant. 2011;17:300–8.</a:t>
+            </a:r>
+            <a:endParaRPr lang="en-US" sz="1100" dirty="0"/>
+          </a:p>
+          <a:p>
+            <a:pPr indent="0" marL="0">
+              <a:spcAft>
+                <a:spcPts val="700"/>
+              </a:spcAft>
+              <a:buNone/>
+            </a:pPr>
+            <a:r>
+              <a:rPr lang="en-US" sz="1100" dirty="0">
+                <a:solidFill>
+                  <a:schemeClr val="tx1"/>
+                </a:solidFill>
+              </a:rPr>
+              <a:t>8. Abboud R, Wan F, Mariotti J, et al. Cytokine release syndrome after haploidentical hematopoietic cell transplantation: an international multicenter analysis. Bone Marrow Transplant. 2021;56:2763–70.</a:t>
             </a:r>
             <a:endParaRPr lang="en-US" sz="1100" dirty="0"/>
           </a:p>
@@ -14879,7 +14801,7 @@
                   <a:schemeClr val="tx1"/>
                 </a:solidFill>
               </a:rPr>
-              <a:t>REFERENCES</a:t>
+              <a:t>BACKUP · PML</a:t>
             </a:r>
             <a:endParaRPr lang="en-US" sz="1100" dirty="0"/>
           </a:p>
@@ -14917,7 +14839,7 @@
                   <a:schemeClr val="tx1"/>
                 </a:solidFill>
               </a:rPr>
-              <a:t>References, part 2 of 2</a:t>
+              <a:t>PML is graded definite, probable or possible on CSF PCR and imaging</a:t>
             </a:r>
             <a:endParaRPr lang="en-US" sz="3600" dirty="0"/>
           </a:p>
@@ -14925,136 +14847,7 @@
       </p:sp>
       <p:sp>
         <p:nvSpPr>
-          <p:cNvPr id="5" name="Text 92"/>
-          <p:cNvSpPr txBox="1"/>
-          <p:nvPr/>
-        </p:nvSpPr>
-        <p:spPr>
-          <a:xfrm>
-            <a:off x="685800" y="2103120"/>
-            <a:ext cx="5120640" cy="3886200"/>
-          </a:xfrm>
-          <a:prstGeom prst="rect">
-            <a:avLst/>
-          </a:prstGeom>
-          <a:noFill/>
-          <a:ln/>
-        </p:spPr>
-        <p:txBody>
-          <a:bodyPr wrap="square" lIns="0" tIns="0" rIns="0" bIns="0" rtlCol="0" anchor="t"/>
-          <a:lstStyle/>
-          <a:p>
-            <a:pPr indent="0" marL="0">
-              <a:spcAft>
-                <a:spcPts val="700"/>
-              </a:spcAft>
-              <a:buNone/>
-            </a:pPr>
-            <a:r>
-              <a:rPr lang="en-US" sz="1100" dirty="0">
-                <a:solidFill>
-                  <a:schemeClr val="tx1"/>
-                </a:solidFill>
-              </a:rPr>
-              <a:t>7. Beitinjaneh A, McKinney AM, Cao Q, Weisdorf DJ. Toxic leukoencephalopathy following fludarabine-associated hematopoietic cell transplantation. Biol Blood Marrow Transplant. 2011;17:300–8.</a:t>
-            </a:r>
-            <a:endParaRPr lang="en-US" sz="1100" dirty="0"/>
-          </a:p>
-          <a:p>
-            <a:pPr indent="0" marL="0">
-              <a:spcAft>
-                <a:spcPts val="700"/>
-              </a:spcAft>
-              <a:buNone/>
-            </a:pPr>
-            <a:r>
-              <a:rPr lang="en-US" sz="1100" dirty="0">
-                <a:solidFill>
-                  <a:schemeClr val="tx1"/>
-                </a:solidFill>
-              </a:rPr>
-              <a:t>8. Hammerstrom AE, Howell J, Gulbis A, et al. Tacrolimus-associated posterior reversible encephalopathy syndrome in hematopoietic allogeneic stem cell transplantation. Am J Hematol. 2013;88:301–5.</a:t>
-            </a:r>
-            <a:endParaRPr lang="en-US" sz="1100" dirty="0"/>
-          </a:p>
-          <a:p>
-            <a:pPr indent="0" marL="0">
-              <a:spcAft>
-                <a:spcPts val="700"/>
-              </a:spcAft>
-              <a:buNone/>
-            </a:pPr>
-            <a:r>
-              <a:rPr lang="en-US" sz="1100" dirty="0">
-                <a:solidFill>
-                  <a:schemeClr val="tx1"/>
-                </a:solidFill>
-              </a:rPr>
-              <a:t>9. Singer S, Grommes C, Reiner AS, et al. Posterior reversible encephalopathy syndrome in patients with cancer. Oncologist. 2015;20:806–11.</a:t>
-            </a:r>
-            <a:endParaRPr lang="en-US" sz="1100" dirty="0"/>
-          </a:p>
-        </p:txBody>
-      </p:sp>
-      <p:sp>
-        <p:nvSpPr>
-          <p:cNvPr id="6" name="Text 93"/>
-          <p:cNvSpPr txBox="1"/>
-          <p:nvPr/>
-        </p:nvSpPr>
-        <p:spPr>
-          <a:xfrm>
-            <a:off x="6400800" y="2103120"/>
-            <a:ext cx="5120640" cy="3886200"/>
-          </a:xfrm>
-          <a:prstGeom prst="rect">
-            <a:avLst/>
-          </a:prstGeom>
-          <a:noFill/>
-          <a:ln/>
-        </p:spPr>
-        <p:txBody>
-          <a:bodyPr wrap="square" lIns="0" tIns="0" rIns="0" bIns="0" rtlCol="0" anchor="t"/>
-          <a:lstStyle/>
-          <a:p>
-            <a:pPr indent="0" marL="0">
-              <a:spcAft>
-                <a:spcPts val="700"/>
-              </a:spcAft>
-              <a:buNone/>
-            </a:pPr>
-            <a:r>
-              <a:rPr lang="en-US" sz="1100" dirty="0">
-                <a:solidFill>
-                  <a:schemeClr val="tx1"/>
-                </a:solidFill>
-              </a:rPr>
-              <a:t>10. Abboud R, Wan F, Mariotti J, et al. Cytokine release syndrome after haploidentical hematopoietic cell transplantation: an international multicenter analysis. Bone Marrow Transplant. 2021;56:2763–70.</a:t>
-            </a:r>
-            <a:endParaRPr lang="en-US" sz="1100" dirty="0"/>
-          </a:p>
-          <a:p>
-            <a:pPr indent="0" marL="0">
-              <a:spcAft>
-                <a:spcPts val="700"/>
-              </a:spcAft>
-              <a:buNone/>
-            </a:pPr>
-            <a:r>
-              <a:rPr lang="en-US" sz="1100" dirty="0">
-                <a:solidFill>
-                  <a:schemeClr val="tx1"/>
-                </a:solidFill>
-              </a:rPr>
-              <a:t>11. Gauthier J, Vermersch P, Chauvet P, et al. Successful treatment with fingolimod of graft-versus-host disease of the central nervous system. Blood Adv. 2018;2:10–3.</a:t>
-            </a:r>
-            <a:endParaRPr lang="en-US" sz="1100" dirty="0"/>
-          </a:p>
-        </p:txBody>
-      </p:sp>
-      <p:sp>
-        <p:nvSpPr>
-          <p:cNvPr id="7" name="Text 0"/>
+          <p:cNvPr id="4" name="Text 0"/>
           <p:cNvSpPr/>
           <p:nvPr>
             <p:ph idx="102" type="body" hasCustomPrompt="1"/>
@@ -15078,182 +14871,6 @@
             <a:pPr algn="l" indent="0" marL="0">
               <a:buNone/>
             </a:pPr>
-            <a:endParaRPr lang="en-US" sz="1000" dirty="0"/>
-          </a:p>
-        </p:txBody>
-      </p:sp>
-      <p:sp>
-        <p:nvSpPr>
-          <p:cNvPr id="25" name="Slide Number Placeholder 0"/>
-          <p:cNvSpPr>
-            <a:spLocks noGrp="1"/>
-          </p:cNvSpPr>
-          <p:nvPr>
-            <p:ph type="sldNum" sz="quarter" idx="4294967295"/>
-          </p:nvPr>
-        </p:nvSpPr>
-        <p:spPr>
-          <a:xfrm>
-            <a:off x="10972800" y="6080760"/>
-            <a:ext cx="530352" cy="274320"/>
-          </a:xfrm>
-          <a:prstGeom prst="rect">
-            <a:avLst/>
-          </a:prstGeom>
-          <a:extLst>
-            <a:ext uri="{C572A759-6A51-4108-AA02-DFA0A04FC94B}">
-              <ma14:wrappingTextBoxFlag xmlns:ma14="http://schemas.microsoft.com/office/mac/drawingml/2011/main" val="0"/>
-            </a:ext>
-          </a:extLst>
-        </p:spPr>
-        <p:txBody>
-          <a:bodyPr/>
-          <a:lstStyle>
-            <a:lvl1pPr>
-              <a:defRPr sz="1000">
-                <a:solidFill>
-                  <a:schemeClr val="tx1"/>
-                </a:solidFill>
-              </a:defRPr>
-            </a:lvl1pPr>
-          </a:lstStyle>
-          <a:p>
-            <a:pPr algn="r"/>
-            <a:fld id="{F7021451-1387-4CA6-816F-3879F97B5CBC}" type="slidenum">
-              <a:rPr b="0" lang="en-US"/>
-              <a:t>24</a:t>
-            </a:fld>
-            <a:endParaRPr lang="en-US"/>
-          </a:p>
-        </p:txBody>
-      </p:sp>
-    </p:spTree>
-  </p:cSld>
-  <p:clrMapOvr>
-    <a:masterClrMapping/>
-  </p:clrMapOvr>
-</p:sld>
-</file>
-
-<file path=ppt/slides/slide25.xml><?xml version="1.0" encoding="utf-8"?>
-<p:sld xmlns:a="http://schemas.openxmlformats.org/drawingml/2006/main" xmlns:r="http://schemas.openxmlformats.org/officeDocument/2006/relationships" xmlns:p="http://schemas.openxmlformats.org/presentationml/2006/main">
-  <p:cSld name="Slide 25">
-    <p:spTree>
-      <p:nvGrpSpPr>
-        <p:cNvPr id="1" name=""/>
-        <p:cNvGrpSpPr/>
-        <p:nvPr/>
-      </p:nvGrpSpPr>
-      <p:grpSpPr>
-        <a:xfrm>
-          <a:off x="0" y="0"/>
-          <a:ext cx="0" cy="0"/>
-          <a:chOff x="0" y="0"/>
-          <a:chExt cx="0" cy="0"/>
-        </a:xfrm>
-      </p:grpSpPr>
-      <p:sp>
-        <p:nvSpPr>
-          <p:cNvPr id="2" name="Text 0"/>
-          <p:cNvSpPr/>
-          <p:nvPr>
-            <p:ph idx="100" type="body" hasCustomPrompt="1"/>
-          </p:nvPr>
-        </p:nvSpPr>
-        <p:spPr>
-          <a:xfrm>
-            <a:off x="685800" y="502920"/>
-            <a:ext cx="10817352" cy="274320"/>
-          </a:xfrm>
-          <a:prstGeom prst="rect">
-            <a:avLst/>
-          </a:prstGeom>
-          <a:noFill/>
-          <a:ln/>
-        </p:spPr>
-        <p:txBody>
-          <a:bodyPr wrap="square" lIns="0" tIns="0" rIns="0" bIns="0" rtlCol="0" anchor="t"/>
-          <a:lstStyle/>
-          <a:p>
-            <a:pPr algn="l" indent="0" marL="0">
-              <a:buNone/>
-            </a:pPr>
-            <a:r>
-              <a:rPr lang="en-US" sz="1100" spc="300" kern="0" dirty="0">
-                <a:solidFill>
-                  <a:schemeClr val="tx1"/>
-                </a:solidFill>
-              </a:rPr>
-              <a:t>BACKUP · BACKUP · PML</a:t>
-            </a:r>
-            <a:endParaRPr lang="en-US" sz="1100" dirty="0"/>
-          </a:p>
-        </p:txBody>
-      </p:sp>
-      <p:sp>
-        <p:nvSpPr>
-          <p:cNvPr id="3" name="Text 0"/>
-          <p:cNvSpPr/>
-          <p:nvPr>
-            <p:ph idx="101" type="title" hasCustomPrompt="1"/>
-          </p:nvPr>
-        </p:nvSpPr>
-        <p:spPr>
-          <a:xfrm>
-            <a:off x="685800" y="822960"/>
-            <a:ext cx="10817352" cy="1143000"/>
-          </a:xfrm>
-          <a:prstGeom prst="rect">
-            <a:avLst/>
-          </a:prstGeom>
-          <a:noFill/>
-          <a:ln/>
-        </p:spPr>
-        <p:txBody>
-          <a:bodyPr wrap="square" lIns="0" tIns="0" rIns="0" bIns="0" rtlCol="0" anchor="t"/>
-          <a:lstStyle/>
-          <a:p>
-            <a:pPr algn="l" indent="0" marL="0">
-              <a:buNone/>
-            </a:pPr>
-            <a:r>
-              <a:rPr lang="en-US" sz="3600" b="1" dirty="0">
-                <a:solidFill>
-                  <a:schemeClr val="tx1"/>
-                </a:solidFill>
-              </a:rPr>
-              <a:t>PML is graded definite, probable or possible on CSF PCR and imaging</a:t>
-            </a:r>
-            <a:endParaRPr lang="en-US" sz="3600" dirty="0"/>
-          </a:p>
-        </p:txBody>
-      </p:sp>
-      <p:sp>
-        <p:nvSpPr>
-          <p:cNvPr id="4" name="Text 0"/>
-          <p:cNvSpPr/>
-          <p:nvPr>
-            <p:ph idx="102" type="body" hasCustomPrompt="1"/>
-          </p:nvPr>
-        </p:nvSpPr>
-        <p:spPr>
-          <a:xfrm>
-            <a:off x="685800" y="6080760"/>
-            <a:ext cx="9966960" cy="457200"/>
-          </a:xfrm>
-          <a:prstGeom prst="rect">
-            <a:avLst/>
-          </a:prstGeom>
-          <a:noFill/>
-          <a:ln/>
-        </p:spPr>
-        <p:txBody>
-          <a:bodyPr wrap="square" lIns="0" tIns="0" rIns="0" bIns="0" rtlCol="0" anchor="t"/>
-          <a:lstStyle/>
-          <a:p>
-            <a:pPr algn="l" indent="0" marL="0">
-              <a:buNone/>
-            </a:pPr>
             <a:r>
               <a:rPr lang="en-US" sz="1000" dirty="0">
                 <a:solidFill>
@@ -15268,7 +14885,7 @@
       </p:sp>
       <p:graphicFrame>
         <p:nvGraphicFramePr>
-          <p:cNvPr id="26" name="Table 94"/>
+          <p:cNvPr id="25" name="Table 91"/>
           <p:cNvGraphicFramePr>
             <a:graphicFrameLocks noGrp="1"/>
           </p:cNvGraphicFramePr>
@@ -15802,7 +15419,7 @@
       </p:graphicFrame>
       <p:sp>
         <p:nvSpPr>
-          <p:cNvPr id="7" name="Text 95"/>
+          <p:cNvPr id="7" name="Text 92"/>
           <p:cNvSpPr txBox="1"/>
           <p:nvPr/>
         </p:nvSpPr>
@@ -15875,7 +15492,7 @@
             <a:pPr algn="r"/>
             <a:fld id="{F7021451-1387-4CA6-816F-3879F97B5CBC}" type="slidenum">
               <a:rPr b="0" lang="en-US"/>
-              <a:t>25</a:t>
+              <a:t>24</a:t>
             </a:fld>
             <a:endParaRPr lang="en-US"/>
           </a:p>
@@ -15889,9 +15506,9 @@
 </p:sld>
 </file>
 
-<file path=ppt/slides/slide26.xml><?xml version="1.0" encoding="utf-8"?>
+<file path=ppt/slides/slide25.xml><?xml version="1.0" encoding="utf-8"?>
 <p:sld xmlns:a="http://schemas.openxmlformats.org/drawingml/2006/main" xmlns:r="http://schemas.openxmlformats.org/officeDocument/2006/relationships" xmlns:p="http://schemas.openxmlformats.org/presentationml/2006/main">
-  <p:cSld name="Slide 26">
+  <p:cSld name="Slide 25">
     <p:spTree>
       <p:nvGrpSpPr>
         <p:cNvPr id="1" name=""/>
@@ -15938,7 +15555,7 @@
                   <a:schemeClr val="tx1"/>
                 </a:solidFill>
               </a:rPr>
-              <a:t>BACKUP · BACKUP · TOXOPLASMA</a:t>
+              <a:t>BACKUP · TOXOPLASMA</a:t>
             </a:r>
             <a:endParaRPr lang="en-US" sz="1100" dirty="0"/>
           </a:p>
@@ -16022,7 +15639,7 @@
       </p:sp>
       <p:graphicFrame>
         <p:nvGraphicFramePr>
-          <p:cNvPr id="27" name="Table 96"/>
+          <p:cNvPr id="26" name="Table 93"/>
           <p:cNvGraphicFramePr>
             <a:graphicFrameLocks noGrp="1"/>
           </p:cNvGraphicFramePr>
@@ -16803,7 +16420,7 @@
       </p:graphicFrame>
       <p:sp>
         <p:nvSpPr>
-          <p:cNvPr id="7" name="Text 97"/>
+          <p:cNvPr id="7" name="Text 94"/>
           <p:cNvSpPr txBox="1"/>
           <p:nvPr/>
         </p:nvSpPr>
@@ -16876,7 +16493,7 @@
             <a:pPr algn="r"/>
             <a:fld id="{F7021451-1387-4CA6-816F-3879F97B5CBC}" type="slidenum">
               <a:rPr b="0" lang="en-US"/>
-              <a:t>26</a:t>
+              <a:t>25</a:t>
             </a:fld>
             <a:endParaRPr lang="en-US"/>
           </a:p>
@@ -16890,9 +16507,9 @@
 </p:sld>
 </file>
 
-<file path=ppt/slides/slide27.xml><?xml version="1.0" encoding="utf-8"?>
+<file path=ppt/slides/slide26.xml><?xml version="1.0" encoding="utf-8"?>
 <p:sld xmlns:a="http://schemas.openxmlformats.org/drawingml/2006/main" xmlns:r="http://schemas.openxmlformats.org/officeDocument/2006/relationships" xmlns:p="http://schemas.openxmlformats.org/presentationml/2006/main">
-  <p:cSld name="Slide 27">
+  <p:cSld name="Slide 26">
     <p:spTree>
       <p:nvGrpSpPr>
         <p:cNvPr id="1" name=""/>
@@ -16939,7 +16556,7 @@
                   <a:schemeClr val="tx1"/>
                 </a:solidFill>
               </a:rPr>
-              <a:t>BACKUP · BACKUP · CNS MOULD INFECTION</a:t>
+              <a:t>BACKUP · CNS MOULD INFECTION</a:t>
             </a:r>
             <a:endParaRPr lang="en-US" sz="1100" dirty="0"/>
           </a:p>
@@ -17023,7 +16640,7 @@
       </p:sp>
       <p:graphicFrame>
         <p:nvGraphicFramePr>
-          <p:cNvPr id="28" name="Table 98"/>
+          <p:cNvPr id="27" name="Table 95"/>
           <p:cNvGraphicFramePr>
             <a:graphicFrameLocks noGrp="1"/>
           </p:cNvGraphicFramePr>
@@ -17841,7 +17458,7 @@
             <a:pPr algn="r"/>
             <a:fld id="{F7021451-1387-4CA6-816F-3879F97B5CBC}" type="slidenum">
               <a:rPr b="0" lang="en-US"/>
-              <a:t>27</a:t>
+              <a:t>26</a:t>
             </a:fld>
             <a:endParaRPr lang="en-US"/>
           </a:p>
@@ -19292,7 +18909,7 @@
                   <a:schemeClr val="tx1"/>
                 </a:solidFill>
               </a:rPr>
-              <a:t>The interval since HCT narrows the list of likely causes</a:t>
+              <a:t>Time since HCT narrows the list of likely causes</a:t>
             </a:r>
             <a:endParaRPr lang="en-US" sz="3600" dirty="0"/>
           </a:p>
@@ -22366,7 +21983,7 @@
                       <a:pPr indent="0" marL="0">
                         <a:buNone/>
                       </a:pPr>
-                      <a:endParaRPr lang="en-US" sz="1500" dirty="0"/>
+                      <a:endParaRPr lang="en-US" sz="1400" dirty="0"/>
                     </a:p>
                   </a:txBody>
                   <a:tcPr marL="25400" marR="101600" marT="63500" marB="63500" anchor="ctr">
@@ -22405,14 +22022,14 @@
                         <a:buNone/>
                       </a:pPr>
                       <a:r>
-                        <a:rPr lang="en-US" sz="1500" b="1" dirty="0">
+                        <a:rPr lang="en-US" sz="1400" b="1" dirty="0">
                           <a:solidFill>
                             <a:schemeClr val="tx1"/>
                           </a:solidFill>
                         </a:rPr>
                         <a:t>Ch. 53 (neurological)</a:t>
                       </a:r>
-                      <a:endParaRPr lang="en-US" sz="1500" dirty="0"/>
+                      <a:endParaRPr lang="en-US" sz="1400" dirty="0"/>
                     </a:p>
                   </a:txBody>
                   <a:tcPr marL="25400" marR="101600" marT="63500" marB="63500" anchor="ctr">
@@ -22451,14 +22068,14 @@
                         <a:buNone/>
                       </a:pPr>
                       <a:r>
-                        <a:rPr lang="en-US" sz="1500" b="1" dirty="0">
+                        <a:rPr lang="en-US" sz="1400" b="1" dirty="0">
                           <a:solidFill>
                             <a:schemeClr val="tx1"/>
                           </a:solidFill>
                         </a:rPr>
                         <a:t>Ch. 42 (endothelial)</a:t>
                       </a:r>
-                      <a:endParaRPr lang="en-US" sz="1500" dirty="0"/>
+                      <a:endParaRPr lang="en-US" sz="1400" dirty="0"/>
                     </a:p>
                   </a:txBody>
                   <a:tcPr marL="25400" marR="101600" marT="63500" marB="63500" anchor="ctr">
@@ -22499,14 +22116,14 @@
                         <a:buNone/>
                       </a:pPr>
                       <a:r>
-                        <a:rPr lang="en-US" sz="1500" dirty="0">
+                        <a:rPr lang="en-US" sz="1400" dirty="0">
                           <a:solidFill>
                             <a:schemeClr val="tx1"/>
                           </a:solidFill>
                         </a:rPr>
                         <a:t>Incidence</a:t>
                       </a:r>
-                      <a:endParaRPr lang="en-US" sz="1500" dirty="0"/>
+                      <a:endParaRPr lang="en-US" sz="1400" dirty="0"/>
                     </a:p>
                   </a:txBody>
                   <a:tcPr marL="25400" marR="101600" marT="63500" marB="63500" anchor="ctr">
@@ -22539,14 +22156,14 @@
                         <a:buNone/>
                       </a:pPr>
                       <a:r>
-                        <a:rPr lang="en-US" sz="1500" dirty="0">
+                        <a:rPr lang="en-US" sz="1400" dirty="0">
                           <a:solidFill>
                             <a:schemeClr val="tx1"/>
                           </a:solidFill>
                         </a:rPr>
                         <a:t>1.6–7.2% of HCT recipients</a:t>
                       </a:r>
-                      <a:endParaRPr lang="en-US" sz="1500" dirty="0"/>
+                      <a:endParaRPr lang="en-US" sz="1400" dirty="0"/>
                     </a:p>
                   </a:txBody>
                   <a:tcPr marL="25400" marR="101600" marT="63500" marB="63500" anchor="ctr">
@@ -22579,14 +22196,14 @@
                         <a:buNone/>
                       </a:pPr>
                       <a:r>
-                        <a:rPr lang="en-US" sz="1500" dirty="0">
+                        <a:rPr lang="en-US" sz="1400" dirty="0">
                           <a:solidFill>
                             <a:schemeClr val="tx1"/>
                           </a:solidFill>
                         </a:rPr>
                         <a:t>About 8% after allo-HCT; 1% haplo, 25% sickle cell</a:t>
                       </a:r>
-                      <a:endParaRPr lang="en-US" sz="1500" dirty="0"/>
+                      <a:endParaRPr lang="en-US" sz="1400" dirty="0"/>
                     </a:p>
                   </a:txBody>
                   <a:tcPr marL="25400" marR="101600" marT="63500" marB="63500" anchor="ctr">
@@ -22621,14 +22238,14 @@
                         <a:buNone/>
                       </a:pPr>
                       <a:r>
-                        <a:rPr lang="en-US" sz="1500" dirty="0">
+                        <a:rPr lang="en-US" sz="1400" dirty="0">
                           <a:solidFill>
                             <a:schemeClr val="tx1"/>
                           </a:solidFill>
                         </a:rPr>
                         <a:t>Mechanism</a:t>
                       </a:r>
-                      <a:endParaRPr lang="en-US" sz="1500" dirty="0"/>
+                      <a:endParaRPr lang="en-US" sz="1400" dirty="0"/>
                     </a:p>
                   </a:txBody>
                   <a:tcPr marL="25400" marR="101600" marT="63500" marB="63500" anchor="ctr">
@@ -22661,14 +22278,14 @@
                         <a:buNone/>
                       </a:pPr>
                       <a:r>
-                        <a:rPr lang="en-US" sz="1500" dirty="0">
+                        <a:rPr lang="en-US" sz="1400" dirty="0">
                           <a:solidFill>
                             <a:schemeClr val="tx1"/>
                           </a:solidFill>
                         </a:rPr>
                         <a:t>Abrupt BP change or cytokine injury to endothelium</a:t>
                       </a:r>
-                      <a:endParaRPr lang="en-US" sz="1500" dirty="0"/>
+                      <a:endParaRPr lang="en-US" sz="1400" dirty="0"/>
                     </a:p>
                   </a:txBody>
                   <a:tcPr marL="25400" marR="101600" marT="63500" marB="63500" anchor="ctr">
@@ -22701,14 +22318,14 @@
                         <a:buNone/>
                       </a:pPr>
                       <a:r>
-                        <a:rPr lang="en-US" sz="1500" dirty="0">
+                        <a:rPr lang="en-US" sz="1400" dirty="0">
                           <a:solidFill>
                             <a:schemeClr val="tx1"/>
                           </a:solidFill>
                         </a:rPr>
                         <a:t>BP surge (30% normal BP) or endothelial leak</a:t>
                       </a:r>
-                      <a:endParaRPr lang="en-US" sz="1500" dirty="0"/>
+                      <a:endParaRPr lang="en-US" sz="1400" dirty="0"/>
                     </a:p>
                   </a:txBody>
                   <a:tcPr marL="25400" marR="101600" marT="63500" marB="63500" anchor="ctr">
@@ -22743,14 +22360,14 @@
                         <a:buNone/>
                       </a:pPr>
                       <a:r>
-                        <a:rPr lang="en-US" sz="1500" dirty="0">
+                        <a:rPr lang="en-US" sz="1400" dirty="0">
                           <a:solidFill>
                             <a:schemeClr val="tx1"/>
                           </a:solidFill>
                         </a:rPr>
                         <a:t>Clues</a:t>
                       </a:r>
-                      <a:endParaRPr lang="en-US" sz="1500" dirty="0"/>
+                      <a:endParaRPr lang="en-US" sz="1400" dirty="0"/>
                     </a:p>
                   </a:txBody>
                   <a:tcPr marL="25400" marR="101600" marT="63500" marB="63500" anchor="ctr">
@@ -22783,14 +22400,14 @@
                         <a:buNone/>
                       </a:pPr>
                       <a:r>
-                        <a:rPr lang="en-US" sz="1500" dirty="0">
+                        <a:rPr lang="en-US" sz="1400" dirty="0">
                           <a:solidFill>
                             <a:schemeClr val="tx1"/>
                           </a:solidFill>
                         </a:rPr>
                         <a:t>Headache, visual change, seizures + renal failure or BP swings</a:t>
                       </a:r>
-                      <a:endParaRPr lang="en-US" sz="1500" dirty="0"/>
+                      <a:endParaRPr lang="en-US" sz="1400" dirty="0"/>
                     </a:p>
                   </a:txBody>
                   <a:tcPr marL="25400" marR="101600" marT="63500" marB="63500" anchor="ctr">
@@ -22823,14 +22440,14 @@
                         <a:buNone/>
                       </a:pPr>
                       <a:r>
-                        <a:rPr lang="en-US" sz="1500" dirty="0">
+                        <a:rPr lang="en-US" sz="1400" dirty="0">
                           <a:solidFill>
                             <a:schemeClr val="tx1"/>
                           </a:solidFill>
                         </a:rPr>
                         <a:t>Encephalopathy, seizures, visual change; CSF normal</a:t>
                       </a:r>
-                      <a:endParaRPr lang="en-US" sz="1500" dirty="0"/>
+                      <a:endParaRPr lang="en-US" sz="1400" dirty="0"/>
                     </a:p>
                   </a:txBody>
                   <a:tcPr marL="25400" marR="101600" marT="63500" marB="63500" anchor="ctr">
@@ -22865,14 +22482,14 @@
                         <a:buNone/>
                       </a:pPr>
                       <a:r>
-                        <a:rPr lang="en-US" sz="1500" dirty="0">
+                        <a:rPr lang="en-US" sz="1400" dirty="0">
                           <a:solidFill>
                             <a:schemeClr val="tx1"/>
                           </a:solidFill>
                         </a:rPr>
                         <a:t>MRI</a:t>
                       </a:r>
-                      <a:endParaRPr lang="en-US" sz="1500" dirty="0"/>
+                      <a:endParaRPr lang="en-US" sz="1400" dirty="0"/>
                     </a:p>
                   </a:txBody>
                   <a:tcPr marL="25400" marR="101600" marT="63500" marB="63500" anchor="ctr">
@@ -22905,14 +22522,14 @@
                         <a:buNone/>
                       </a:pPr>
                       <a:r>
-                        <a:rPr lang="en-US" sz="1500" dirty="0">
+                        <a:rPr lang="en-US" sz="1400" dirty="0">
                           <a:solidFill>
                             <a:schemeClr val="tx1"/>
                           </a:solidFill>
                         </a:rPr>
                         <a:t>Bilateral parieto-occipital T2 lesions; MRI more sensitive than CT</a:t>
                       </a:r>
-                      <a:endParaRPr lang="en-US" sz="1500" dirty="0"/>
+                      <a:endParaRPr lang="en-US" sz="1400" dirty="0"/>
                     </a:p>
                   </a:txBody>
                   <a:tcPr marL="25400" marR="101600" marT="63500" marB="63500" anchor="ctr">
@@ -22945,14 +22562,14 @@
                         <a:buNone/>
                       </a:pPr>
                       <a:r>
-                        <a:rPr lang="en-US" sz="1500" dirty="0">
+                        <a:rPr lang="en-US" sz="1400" dirty="0">
                           <a:solidFill>
                             <a:schemeClr val="tx1"/>
                           </a:solidFill>
                         </a:rPr>
                         <a:t>Bilateral parieto-occipital edema on T2/FLAIR</a:t>
                       </a:r>
-                      <a:endParaRPr lang="en-US" sz="1500" dirty="0"/>
+                      <a:endParaRPr lang="en-US" sz="1400" dirty="0"/>
                     </a:p>
                   </a:txBody>
                   <a:tcPr marL="25400" marR="101600" marT="63500" marB="63500" anchor="ctr">
@@ -22987,14 +22604,14 @@
                         <a:buNone/>
                       </a:pPr>
                       <a:r>
-                        <a:rPr lang="en-US" sz="1500" dirty="0">
+                        <a:rPr lang="en-US" sz="1400" dirty="0">
                           <a:solidFill>
                             <a:schemeClr val="tx1"/>
                           </a:solidFill>
                         </a:rPr>
-                        <a:t>CNI</a:t>
+                        <a:t>Risk factors</a:t>
                       </a:r>
-                      <a:endParaRPr lang="en-US" sz="1500" dirty="0"/>
+                      <a:endParaRPr lang="en-US" sz="1400" dirty="0"/>
                     </a:p>
                   </a:txBody>
                   <a:tcPr marL="25400" marR="101600" marT="63500" marB="63500" anchor="ctr">
@@ -23027,14 +22644,14 @@
                         <a:buNone/>
                       </a:pPr>
                       <a:r>
-                        <a:rPr lang="en-US" sz="1500" dirty="0">
+                        <a:rPr lang="en-US" sz="1400" dirty="0">
                           <a:solidFill>
                             <a:schemeClr val="tx1"/>
                           </a:solidFill>
                         </a:rPr>
-                        <a:t>Reversible after CNI withdrawal if diagnosed early</a:t>
+                        <a:t>Renal failure, BP swings; voriconazole raises CNI levels</a:t>
                       </a:r>
-                      <a:endParaRPr lang="en-US" sz="1500" dirty="0"/>
+                      <a:endParaRPr lang="en-US" sz="1400" dirty="0"/>
                     </a:p>
                   </a:txBody>
                   <a:tcPr marL="25400" marR="101600" marT="63500" marB="63500" anchor="ctr">
@@ -23067,14 +22684,14 @@
                         <a:buNone/>
                       </a:pPr>
                       <a:r>
-                        <a:rPr lang="en-US" sz="1500" dirty="0">
+                        <a:rPr lang="en-US" sz="1400" dirty="0">
                           <a:solidFill>
                             <a:schemeClr val="tx1"/>
                           </a:solidFill>
                         </a:rPr>
-                        <a:t>Stopping or switching the CNI did not change the course</a:t>
+                        <a:t>Hypertension, CNI, fludarabine, low Mg, aGVHD II–IV</a:t>
                       </a:r>
-                      <a:endParaRPr lang="en-US" sz="1500" dirty="0"/>
+                      <a:endParaRPr lang="en-US" sz="1400" dirty="0"/>
                     </a:p>
                   </a:txBody>
                   <a:tcPr marL="25400" marR="101600" marT="63500" marB="63500" anchor="ctr">
@@ -23109,14 +22726,14 @@
                         <a:buNone/>
                       </a:pPr>
                       <a:r>
-                        <a:rPr lang="en-US" sz="1500" dirty="0">
+                        <a:rPr lang="en-US" sz="1400" dirty="0">
                           <a:solidFill>
                             <a:schemeClr val="tx1"/>
                           </a:solidFill>
                         </a:rPr>
-                        <a:t>Outcome</a:t>
+                        <a:t>CNI</a:t>
                       </a:r>
-                      <a:endParaRPr lang="en-US" sz="1500" dirty="0"/>
+                      <a:endParaRPr lang="en-US" sz="1400" dirty="0"/>
                     </a:p>
                   </a:txBody>
                   <a:tcPr marL="25400" marR="101600" marT="63500" marB="63500" anchor="ctr">
@@ -23129,7 +22746,7 @@
                     <a:lnT w="0" cap="flat" cmpd="sng" algn="ctr">
                       <a:noFill/>
                     </a:lnT>
-                    <a:lnB w="19050" cap="flat" cmpd="sng" algn="ctr">
+                    <a:lnB w="6350" cap="flat" cmpd="sng" algn="ctr">
                       <a:solidFill>
                         <a:srgbClr val="000000"/>
                       </a:solidFill>
@@ -23149,14 +22766,14 @@
                         <a:buNone/>
                       </a:pPr>
                       <a:r>
-                        <a:rPr lang="en-US" sz="1500" dirty="0">
+                        <a:rPr lang="en-US" sz="1400" dirty="0">
                           <a:solidFill>
                             <a:schemeClr val="tx1"/>
                           </a:solidFill>
                         </a:rPr>
-                        <a:t>Sequelae if not rapidly diagnosed and treated</a:t>
+                        <a:t>Reversible after CNI withdrawal if diagnosed early</a:t>
                       </a:r>
-                      <a:endParaRPr lang="en-US" sz="1500" dirty="0"/>
+                      <a:endParaRPr lang="en-US" sz="1400" dirty="0"/>
                     </a:p>
                   </a:txBody>
                   <a:tcPr marL="25400" marR="101600" marT="63500" marB="63500" anchor="ctr">
@@ -23169,7 +22786,7 @@
                     <a:lnT w="0" cap="flat" cmpd="sng" algn="ctr">
                       <a:noFill/>
                     </a:lnT>
-                    <a:lnB w="19050" cap="flat" cmpd="sng" algn="ctr">
+                    <a:lnB w="6350" cap="flat" cmpd="sng" algn="ctr">
                       <a:solidFill>
                         <a:srgbClr val="000000"/>
                       </a:solidFill>
@@ -23189,14 +22806,136 @@
                         <a:buNone/>
                       </a:pPr>
                       <a:r>
-                        <a:rPr lang="en-US" sz="1500" dirty="0">
+                        <a:rPr lang="en-US" sz="1400" dirty="0">
+                          <a:solidFill>
+                            <a:schemeClr val="tx1"/>
+                          </a:solidFill>
+                        </a:rPr>
+                        <a:t>Stopping or switching the CNI did not change the course</a:t>
+                      </a:r>
+                      <a:endParaRPr lang="en-US" sz="1400" dirty="0"/>
+                    </a:p>
+                  </a:txBody>
+                  <a:tcPr marL="25400" marR="101600" marT="63500" marB="63500" anchor="ctr">
+                    <a:lnL w="0" cap="flat" cmpd="sng" algn="ctr">
+                      <a:noFill/>
+                    </a:lnL>
+                    <a:lnR w="0" cap="flat" cmpd="sng" algn="ctr">
+                      <a:noFill/>
+                    </a:lnR>
+                    <a:lnT w="0" cap="flat" cmpd="sng" algn="ctr">
+                      <a:noFill/>
+                    </a:lnT>
+                    <a:lnB w="6350" cap="flat" cmpd="sng" algn="ctr">
+                      <a:solidFill>
+                        <a:srgbClr val="000000"/>
+                      </a:solidFill>
+                      <a:prstDash val="solid"/>
+                      <a:round/>
+                      <a:headEnd type="none" w="med" len="med"/>
+                      <a:tailEnd type="none" w="med" len="med"/>
+                    </a:lnB>
+                  </a:tcPr>
+                </a:tc>
+              </a:tr>
+              <a:tr h="0">
+                <a:tc>
+                  <a:txBody>
+                    <a:bodyPr/>
+                    <a:lstStyle/>
+                    <a:p>
+                      <a:pPr indent="0" marL="0">
+                        <a:buNone/>
+                      </a:pPr>
+                      <a:r>
+                        <a:rPr lang="en-US" sz="1400" dirty="0">
+                          <a:solidFill>
+                            <a:schemeClr val="tx1"/>
+                          </a:solidFill>
+                        </a:rPr>
+                        <a:t>Outcome</a:t>
+                      </a:r>
+                      <a:endParaRPr lang="en-US" sz="1400" dirty="0"/>
+                    </a:p>
+                  </a:txBody>
+                  <a:tcPr marL="25400" marR="101600" marT="63500" marB="63500" anchor="ctr">
+                    <a:lnL w="0" cap="flat" cmpd="sng" algn="ctr">
+                      <a:noFill/>
+                    </a:lnL>
+                    <a:lnR w="0" cap="flat" cmpd="sng" algn="ctr">
+                      <a:noFill/>
+                    </a:lnR>
+                    <a:lnT w="0" cap="flat" cmpd="sng" algn="ctr">
+                      <a:noFill/>
+                    </a:lnT>
+                    <a:lnB w="19050" cap="flat" cmpd="sng" algn="ctr">
+                      <a:solidFill>
+                        <a:srgbClr val="000000"/>
+                      </a:solidFill>
+                      <a:prstDash val="solid"/>
+                      <a:round/>
+                      <a:headEnd type="none" w="med" len="med"/>
+                      <a:tailEnd type="none" w="med" len="med"/>
+                    </a:lnB>
+                  </a:tcPr>
+                </a:tc>
+                <a:tc>
+                  <a:txBody>
+                    <a:bodyPr/>
+                    <a:lstStyle/>
+                    <a:p>
+                      <a:pPr indent="0" marL="0">
+                        <a:buNone/>
+                      </a:pPr>
+                      <a:r>
+                        <a:rPr lang="en-US" sz="1400" dirty="0">
+                          <a:solidFill>
+                            <a:schemeClr val="tx1"/>
+                          </a:solidFill>
+                        </a:rPr>
+                        <a:t>Sequelae if not rapidly diagnosed and treated</a:t>
+                      </a:r>
+                      <a:endParaRPr lang="en-US" sz="1400" dirty="0"/>
+                    </a:p>
+                  </a:txBody>
+                  <a:tcPr marL="25400" marR="101600" marT="63500" marB="63500" anchor="ctr">
+                    <a:lnL w="0" cap="flat" cmpd="sng" algn="ctr">
+                      <a:noFill/>
+                    </a:lnL>
+                    <a:lnR w="0" cap="flat" cmpd="sng" algn="ctr">
+                      <a:noFill/>
+                    </a:lnR>
+                    <a:lnT w="0" cap="flat" cmpd="sng" algn="ctr">
+                      <a:noFill/>
+                    </a:lnT>
+                    <a:lnB w="19050" cap="flat" cmpd="sng" algn="ctr">
+                      <a:solidFill>
+                        <a:srgbClr val="000000"/>
+                      </a:solidFill>
+                      <a:prstDash val="solid"/>
+                      <a:round/>
+                      <a:headEnd type="none" w="med" len="med"/>
+                      <a:tailEnd type="none" w="med" len="med"/>
+                    </a:lnB>
+                  </a:tcPr>
+                </a:tc>
+                <a:tc>
+                  <a:txBody>
+                    <a:bodyPr/>
+                    <a:lstStyle/>
+                    <a:p>
+                      <a:pPr indent="0" marL="0">
+                        <a:buNone/>
+                      </a:pPr>
+                      <a:r>
+                        <a:rPr lang="en-US" sz="1400" dirty="0">
                           <a:solidFill>
                             <a:schemeClr val="tx1"/>
                           </a:solidFill>
                         </a:rPr>
                         <a:t>&gt;80% resolve rapidly; no effect on TRM or survival</a:t>
                       </a:r>
-                      <a:endParaRPr lang="en-US" sz="1500" dirty="0"/>
+                      <a:endParaRPr lang="en-US" sz="1400" dirty="0"/>
                     </a:p>
                   </a:txBody>
                   <a:tcPr marL="25400" marR="101600" marT="63500" marB="63500" anchor="ctr">
@@ -23225,42 +22964,6 @@
           </a:graphicData>
         </a:graphic>
       </p:graphicFrame>
-      <p:sp>
-        <p:nvSpPr>
-          <p:cNvPr id="7" name="Text 43"/>
-          <p:cNvSpPr txBox="1"/>
-          <p:nvPr/>
-        </p:nvSpPr>
-        <p:spPr>
-          <a:xfrm>
-            <a:off x="685800" y="5486400"/>
-            <a:ext cx="10817352" cy="411480"/>
-          </a:xfrm>
-          <a:prstGeom prst="rect">
-            <a:avLst/>
-          </a:prstGeom>
-          <a:noFill/>
-          <a:ln/>
-        </p:spPr>
-        <p:txBody>
-          <a:bodyPr wrap="square" lIns="0" tIns="0" rIns="0" bIns="0" rtlCol="0" anchor="t"/>
-          <a:lstStyle/>
-          <a:p>
-            <a:pPr indent="0" marL="0">
-              <a:buNone/>
-            </a:pPr>
-            <a:r>
-              <a:rPr lang="en-US" sz="1600" b="1" dirty="0">
-                <a:solidFill>
-                  <a:schemeClr val="tx1"/>
-                </a:solidFill>
-              </a:rPr>
-              <a:t>Ch. 42 risk factors: hypertension, CNI, fludarabine, HCT for hemoglobinopathy, low Mg, aGVHD II–IV (Hammerstrom 2013; Singer 2015)</a:t>
-            </a:r>
-            <a:endParaRPr lang="en-US" sz="1600" dirty="0"/>
-          </a:p>
-        </p:txBody>
-      </p:sp>
       <p:sp>
         <p:nvSpPr>
           <p:cNvPr id="25" name="Slide Number Placeholder 0"/>
@@ -23447,7 +23150,7 @@
       </p:sp>
       <p:graphicFrame>
         <p:nvGraphicFramePr>
-          <p:cNvPr id="10" name="Table 44"/>
+          <p:cNvPr id="10" name="Table 43"/>
           <p:cNvGraphicFramePr>
             <a:graphicFrameLocks noGrp="1"/>
           </p:cNvGraphicFramePr>
@@ -24220,7 +23923,7 @@
       </p:graphicFrame>
       <p:sp>
         <p:nvSpPr>
-          <p:cNvPr id="7" name="Text 45"/>
+          <p:cNvPr id="7" name="Text 44"/>
           <p:cNvSpPr txBox="1"/>
           <p:nvPr/>
         </p:nvSpPr>

</xml_diff>

<commit_message>
Slides: sessions 04 and 22; others in progress
Co-Authored-By: Claude Opus 5.5 <noreply@anthropic.com>
Claude-Session: https://claude.ai/code/session_01XkzKv8pUGMF9AsqSCMpnBq
</commit_message>
<xml_diff>
--- a/slides/decks/s16-neurological.pptx
+++ b/slides/decks/s16-neurological.pptx
@@ -132,20 +132,20 @@
   <p:extLst>
     <p:ext uri="{521415D9-36F7-43E2-AB2F-B90AF26B5E84}">
       <p14:sectionLst xmlns:p14="http://schemas.microsoft.com/office/powerpoint/2010/main">
-        <p14:section name="Opening" id="{b5fee39f-2e5d-77fe-719b-4371d239a9b8}">
+        <p14:section name="Opening" id="{ecb10a20-da5c-c5e1-c2db-09e72f438e4b}">
           <p14:sldIdLst>
             <p14:sldId id="256"/>
             <p14:sldId id="257"/>
           </p14:sldIdLst>
         </p14:section>
-        <p14:section name="Scope and causes" id="{661ee6bc-fd7c-73fe-31a6-c99d43ecfc88}">
+        <p14:section name="Scope and causes" id="{7db2a5ae-b850-2b32-a64e-66703574c7ed}">
           <p14:sldIdLst>
             <p14:sldId id="258"/>
             <p14:sldId id="259"/>
             <p14:sldId id="260"/>
           </p14:sldIdLst>
         </p14:section>
-        <p14:section name="Neurotoxic drugs and PRES" id="{db64a90d-d6df-1e12-3778-d52f278059f1}">
+        <p14:section name="Neurotoxic drugs and PRES" id="{43536381-1a4b-84cf-e771-09e28617cc97}">
           <p14:sldIdLst>
             <p14:sldId id="261"/>
             <p14:sldId id="262"/>
@@ -153,7 +153,7 @@
             <p14:sldId id="264"/>
           </p14:sldIdLst>
         </p14:section>
-        <p14:section name="Infection, vascular, metabolic, immune" id="{f1cf36a1-d3a3-a91e-332e-8be9f4cc7726}">
+        <p14:section name="Infection, vascular, metabolic, immune" id="{3f0dcf26-4185-71e8-4dcf-151d490975dc}">
           <p14:sldIdLst>
             <p14:sldId id="265"/>
             <p14:sldId id="266"/>
@@ -162,13 +162,13 @@
             <p14:sldId id="269"/>
           </p14:sldIdLst>
         </p14:section>
-        <p14:section name="Work-up" id="{3f120cba-37f4-bc74-04a6-5a0cfa61b68d}">
+        <p14:section name="Work-up" id="{4568baac-e5a4-0648-5d40-07bfc590a804}">
           <p14:sldIdLst>
             <p14:sldId id="270"/>
             <p14:sldId id="271"/>
           </p14:sldIdLst>
         </p14:section>
-        <p14:section name="Board questions" id="{075e5961-e302-4235-ba16-811f2848be7b}">
+        <p14:section name="Board questions" id="{dd30e100-c830-76cf-ac43-470403b77acb}">
           <p14:sldIdLst>
             <p14:sldId id="272"/>
             <p14:sldId id="273"/>
@@ -178,12 +178,12 @@
             <p14:sldId id="277"/>
           </p14:sldIdLst>
         </p14:section>
-        <p14:section name="References" id="{6bb0496f-1a95-6edd-51cc-92eae5eadc62}">
+        <p14:section name="References" id="{ba98ea0b-6b08-8aa7-b232-02d8261d220e}">
           <p14:sldIdLst>
             <p14:sldId id="278"/>
           </p14:sldIdLst>
         </p14:section>
-        <p14:section name="Backup" id="{d4a29e2d-97bc-0cc0-dcf5-8733b621a3d3}">
+        <p14:section name="Backup" id="{cd07272f-05ce-d4eb-c226-e706e6e1ab29}">
           <p14:sldIdLst>
             <p14:sldId id="279"/>
             <p14:sldId id="280"/>
@@ -1708,6 +1708,17 @@
               <a:t>考試若問第一步做什麼，答案通常是回顧用藥史和代謝問題，而不是直接做切片。</a:t>
             </a:r>
           </a:p>
+          <a:p>
+            <a:pPr>
+              <a:spcAft>
+                <a:spcPts val="600"/>
+              </a:spcAft>
+            </a:pPr>
+            <a:r>
+              <a:rPr lang="en-US" dirty="0"/>
+              <a:t>CSF 也用來找原本血液疾病在 CNS 的復發，這個目的常常被忘記，送檢時要一併安排。</a:t>
+            </a:r>
+          </a:p>
         </p:txBody>
       </p:sp>
       <p:sp>
@@ -3485,6 +3496,17 @@
             <a:r>
               <a:rPr lang="en-US" dirty="0"/>
               <a:t>臨床症狀常常不典型，時間點是少數可以快速縮小範圍的線索。</a:t>
+            </a:r>
+          </a:p>
+          <a:p>
+            <a:pPr>
+              <a:spcAft>
+                <a:spcPts val="600"/>
+              </a:spcAft>
+            </a:pPr>
+            <a:r>
+              <a:rPr lang="en-US" dirty="0"/>
+              <a:t>所以先問移植第幾天、用什麼藥、有沒有 GVHD，就能把七大類縮成兩三類。</a:t>
             </a:r>
           </a:p>
         </p:txBody>

</xml_diff>